<commit_message>
feat(calculus): redraw Figure 1 as a funnel/sieve (preconception filters out the outer question)
Co-Authored-By: Tatsuki Onishi <bougtoir@gmail.com>
</commit_message>
<xml_diff>
--- a/calculus_of_lives/output/figures_en.pptx
+++ b/calculus_of_lives/output/figures_en.pptx
@@ -3140,8 +3140,8 @@
         </p:blipFill>
         <p:spPr>
           <a:xfrm>
-            <a:off x="2562938" y="1051560"/>
-            <a:ext cx="7065818" cy="4572000"/>
+            <a:off x="3479966" y="1051560"/>
+            <a:ext cx="5231763" cy="4572000"/>
           </a:xfrm>
           <a:prstGeom prst="rect">
             <a:avLst/>
@@ -3176,7 +3176,7 @@
                   <a:srgbClr val="404040"/>
                 </a:solidFill>
               </a:rPr>
-              <a:t>Figure 1. Two layers of the question. The standard “was it necessary?” debate audits a weighing from inside the calculus; the ethical question asks, from outside, whether such a weighing is ours to perform.</a:t>
+              <a:t>Figure 1. The funnel of attention. Every question the bombing raises enters at the top, but a layer of common sense and preconception—that we are entitled to do the weighing—acts as a sieve: only the inner, technical (“was it necessary?”) question passes through into public debate, while the outer question—whether such weighing is ours to perform at all—is screened out and never comes into view.</a:t>
             </a:r>
           </a:p>
         </p:txBody>

</xml_diff>